<commit_message>
Clarify CUPC poster mass comparison and conclusions
</commit_message>
<xml_diff>
--- a/CUPC_Poster.pptx
+++ b/CUPC_Poster.pptx
@@ -129,7 +129,7 @@
   <pc:docChgLst>
     <pc:chgData name="Nicole Jiang" userId="09ef0fc0f6f473b5" providerId="LiveId" clId="{EB8F4A53-0964-5BF1-90AD-931457E28E1A}"/>
     <pc:docChg chg="undo redo custSel addSld delSld modSld">
-      <pc:chgData name="Nicole Jiang" userId="09ef0fc0f6f473b5" providerId="LiveId" clId="{EB8F4A53-0964-5BF1-90AD-931457E28E1A}" dt="2026-10-13T21:09:01.692" v="2393" actId="1076"/>
+      <pc:chgData name="Nicole Jiang" userId="09ef0fc0f6f473b5" providerId="LiveId" clId="{EB8F4A53-0964-5BF1-90AD-931457E28E1A}" dt="2026-10-14T01:47:21.679" v="2444" actId="20577"/>
       <pc:docMkLst>
         <pc:docMk/>
       </pc:docMkLst>
@@ -141,7 +141,7 @@
         </pc:sldMkLst>
       </pc:sldChg>
       <pc:sldChg chg="modSp mod">
-        <pc:chgData name="Nicole Jiang" userId="09ef0fc0f6f473b5" providerId="LiveId" clId="{EB8F4A53-0964-5BF1-90AD-931457E28E1A}" dt="2026-10-13T21:09:01.692" v="2393" actId="1076"/>
+        <pc:chgData name="Nicole Jiang" userId="09ef0fc0f6f473b5" providerId="LiveId" clId="{EB8F4A53-0964-5BF1-90AD-931457E28E1A}" dt="2026-10-14T01:47:21.679" v="2444" actId="20577"/>
         <pc:sldMkLst>
           <pc:docMk/>
           <pc:sldMk cId="868487171" sldId="260"/>
@@ -179,7 +179,7 @@
           </ac:spMkLst>
         </pc:spChg>
         <pc:spChg chg="mod">
-          <ac:chgData name="Nicole Jiang" userId="09ef0fc0f6f473b5" providerId="LiveId" clId="{EB8F4A53-0964-5BF1-90AD-931457E28E1A}" dt="2026-10-13T21:08:30.689" v="2388" actId="255"/>
+          <ac:chgData name="Nicole Jiang" userId="09ef0fc0f6f473b5" providerId="LiveId" clId="{EB8F4A53-0964-5BF1-90AD-931457E28E1A}" dt="2026-10-14T01:47:21.679" v="2444" actId="20577"/>
           <ac:spMkLst>
             <pc:docMk/>
             <pc:sldMk cId="868487171" sldId="260"/>
@@ -650,7 +650,7 @@
           <a:bodyPr/>
           <a:lstStyle/>
           <a:p>
-            <a:endParaRPr lang="en-US"/>
+            <a:endParaRPr lang="en-US" dirty="0"/>
           </a:p>
           <a:p>
             <a:pPr>
@@ -660,10 +660,82 @@
               <a:buNone/>
             </a:pPr>
             <a:r>
-              <a:rPr lang="en-CA" sz="1200" b="0">
+              <a:rPr lang="en-CA" sz="1200" b="0" dirty="0">
                 <a:latin typeface="Aptos"/>
               </a:rPr>
-              <a:t>Poster figure inputs: results/manuscript/tables/publication_object_selection.csv; mass_offset_object_sensitivity.csv; results/v3/tables/v3_object_point_ranking.csv and v3_object_uncertainty_ranking.csv; results/v4/tables/v4_minimum_seed_mass.csv. Controlled growth comparison uses src.models.predicted_log_mbh with mean ratio 1, z_seed=30, B_merge=1 and efficiencies 0.1 and 1-sqrt(8/9). Independent dynamical mass: https://arxiv.org/abs/2508.21748.</a:t>
+              <a:t>Poster figure inputs: results/manuscript/tables/</a:t>
+            </a:r>
+            <a:r>
+              <a:rPr lang="en-CA" sz="1200" b="0" dirty="0" err="1">
+                <a:latin typeface="Aptos"/>
+              </a:rPr>
+              <a:t>publication_object_selection.csv</a:t>
+            </a:r>
+            <a:r>
+              <a:rPr lang="en-CA" sz="1200" b="0" dirty="0">
+                <a:latin typeface="Aptos"/>
+              </a:rPr>
+              <a:t>; </a:t>
+            </a:r>
+            <a:r>
+              <a:rPr lang="en-CA" sz="1200" b="0" dirty="0" err="1">
+                <a:latin typeface="Aptos"/>
+              </a:rPr>
+              <a:t>mass_offset_object_sensitivity.csv</a:t>
+            </a:r>
+            <a:r>
+              <a:rPr lang="en-CA" sz="1200" b="0" dirty="0">
+                <a:latin typeface="Aptos"/>
+              </a:rPr>
+              <a:t>; results/v3/tables/v3_object_point_ranking.csv and v3_object_uncertainty_ranking.csv; results/v4/tables/v4_minimum_seed_mass.csv. Controlled growth comparison uses </a:t>
+            </a:r>
+            <a:r>
+              <a:rPr lang="en-CA" sz="1200" b="0" dirty="0" err="1">
+                <a:latin typeface="Aptos"/>
+              </a:rPr>
+              <a:t>src.models.predicted_log_mbh</a:t>
+            </a:r>
+            <a:r>
+              <a:rPr lang="en-CA" sz="1200" b="0" dirty="0">
+                <a:latin typeface="Aptos"/>
+              </a:rPr>
+              <a:t> with mean ratio 1, </a:t>
+            </a:r>
+            <a:r>
+              <a:rPr lang="en-CA" sz="1200" b="0" dirty="0" err="1">
+                <a:latin typeface="Aptos"/>
+              </a:rPr>
+              <a:t>z_seed</a:t>
+            </a:r>
+            <a:r>
+              <a:rPr lang="en-CA" sz="1200" b="0" dirty="0">
+                <a:latin typeface="Aptos"/>
+              </a:rPr>
+              <a:t>=30, </a:t>
+            </a:r>
+            <a:r>
+              <a:rPr lang="en-CA" sz="1200" b="0" dirty="0" err="1">
+                <a:latin typeface="Aptos"/>
+              </a:rPr>
+              <a:t>B_merge</a:t>
+            </a:r>
+            <a:r>
+              <a:rPr lang="en-CA" sz="1200" b="0" dirty="0">
+                <a:latin typeface="Aptos"/>
+              </a:rPr>
+              <a:t>=1 and efficiencies 0.1 and 1-sqrt(8/9). Independent dynamical mass: https://</a:t>
+            </a:r>
+            <a:r>
+              <a:rPr lang="en-CA" sz="1200" b="0" dirty="0" err="1">
+                <a:latin typeface="Aptos"/>
+              </a:rPr>
+              <a:t>arxiv.org</a:t>
+            </a:r>
+            <a:r>
+              <a:rPr lang="en-CA" sz="1200" b="0" dirty="0">
+                <a:latin typeface="Aptos"/>
+              </a:rPr>
+              <a:t>/abs/2508.21748.</a:t>
             </a:r>
           </a:p>
         </p:txBody>
@@ -4883,16 +4955,16 @@
               <a:buNone/>
             </a:pPr>
             <a:r>
-              <a:rPr lang="en-CA" sz="3300" b="1" dirty="0">
+              <a:rPr sz="3300" b="1" lang="en-CA">
                 <a:latin typeface="Aptos"/>
               </a:rPr>
               <a:t>How did early black holes grow so big, so fast? </a:t>
             </a:r>
             <a:r>
-              <a:rPr lang="en-CA" sz="3300" b="0" dirty="0">
+              <a:rPr sz="3300" b="0" lang="en-CA">
                 <a:latin typeface="Aptos"/>
               </a:rPr>
-              <a:t>The James Webb Space Telescope (JWST) has revealed massive black holes with little time to assemble. My research builds a standardized catalogue across studies, then tests objects against analytic growth models to identify the strongest constraints and how they depend on the assumptions.</a:t>
+              <a:t>The James Webb Space Telescope (JWST) has revealed massive black holes with little time to grow. I compiled published mass estimates and calculated the average accretion needed to reach each mass under different seed masses (initial masses), start times, and radiative efficiencies.</a:t>
             </a:r>
           </a:p>
         </p:txBody>
@@ -5029,7 +5101,7 @@
             <p:spPr>
               <a:xfrm>
                 <a:off x="1371600" y="11567160"/>
-                <a:ext cx="12573000" cy="12300611"/>
+                <a:ext cx="12573000" cy="13888226"/>
               </a:xfrm>
               <a:prstGeom prst="rect">
                 <a:avLst/>
@@ -5137,16 +5209,16 @@
                   <a:buNone/>
                 </a:pPr>
                 <a:r>
-                  <a:rPr sz="3300" b="1" i="0" lang="en-CA">
+                  <a:rPr sz="3300" b="1" lang="en-CA">
                     <a:latin typeface="Aptos"/>
                   </a:rPr>
                   <a:t>Model tests: </a:t>
                 </a:r>
                 <a:r>
-                  <a:rPr sz="3300" b="0" i="0" lang="en-CA">
-                    <a:latin typeface="Aptos"/>
-                  </a:rPr>
-                  <a:t>Calculated the average Eddington ratio required to reach each observed mass. Ranked these requirements and compared them with each model’s allowed average.</a:t>
+                  <a:rPr sz="3300" b="0" lang="en-CA">
+                    <a:latin typeface="Aptos"/>
+                  </a:rPr>
+                  <a:t>Calculated and ranked the lifetime-average Eddington ratios needed to reach each observed mass. Compared them with assumed caps: 1 for the reference test and 0.3, 1, or 2 for earlier-onset tests.</a:t>
                 </a:r>
               </a:p>
               <a:p>
@@ -5566,47 +5638,58 @@
                   <a:buNone/>
                 </a:pPr>
                 <a:r>
-                  <a:rPr sz="3300" b="1" i="0" lang="en-CA">
+                  <a:rPr lang="en-CA" sz="3300" b="1" i="0" dirty="0">
                     <a:latin typeface="Aptos"/>
                   </a:rPr>
                   <a:t>Eddington ratio: </a:t>
                 </a:r>
                 <a:r>
-                  <a:rPr sz="3300" b="0" i="1" lang="en-CA">
+                  <a:rPr lang="en-CA" sz="3300" b="0" i="1" dirty="0" err="1">
                     <a:latin typeface="Aptos"/>
                   </a:rPr>
                   <a:t>f</a:t>
                 </a:r>
                 <a:r>
-                  <a:rPr sz="2200" b="0" i="0" lang="en-CA" baseline="-25000">
+                  <a:rPr lang="en-CA" sz="2200" b="0" i="0" baseline="-25000" dirty="0" err="1">
                     <a:latin typeface="Aptos"/>
                   </a:rPr>
                   <a:t>Edd</a:t>
                 </a:r>
                 <a:r>
-                  <a:rPr sz="3300" b="0" i="0" lang="en-CA">
-                    <a:latin typeface="Aptos"/>
-                  </a:rPr>
-                  <a:t>: luminosity/Eddington limit.</a:t>
-                </a:r>
-                <a:br/>
-                <a:r>
-                  <a:rPr sz="3300" b="0" i="1" lang="en-CA">
+                  <a:rPr lang="en-CA" sz="3300" b="0" i="0" dirty="0">
+                    <a:latin typeface="Aptos"/>
+                  </a:rPr>
+                  <a:t> </a:t>
+                </a:r>
+                <a:r>
+                  <a:rPr lang="en-CA" sz="3300" b="1" i="0" dirty="0">
+                    <a:latin typeface="Aptos"/>
+                  </a:rPr>
+                  <a:t>: </a:t>
+                </a:r>
+                <a:r>
+                  <a:rPr lang="en-CA" sz="3300" b="0" i="0" dirty="0">
+                    <a:latin typeface="Aptos"/>
+                  </a:rPr>
+                  <a:t>luminosity/Eddington limit;  </a:t>
+                </a:r>
+                <a:r>
+                  <a:rPr lang="en-CA" sz="3300" b="0" i="1" dirty="0" err="1">
                     <a:latin typeface="Aptos"/>
                   </a:rPr>
                   <a:t>f̄</a:t>
                 </a:r>
                 <a:r>
-                  <a:rPr sz="2200" b="0" i="0" lang="en-CA" baseline="-25000">
+                  <a:rPr lang="en-CA" sz="2200" b="0" i="0" baseline="-25000" dirty="0" err="1">
                     <a:latin typeface="Aptos"/>
                   </a:rPr>
                   <a:t>Edd,req</a:t>
                 </a:r>
                 <a:r>
-                  <a:rPr sz="3300" b="0" i="0" lang="en-CA">
-                    <a:latin typeface="Aptos"/>
-                  </a:rPr>
-                  <a:t>: required lifetime average, including inactive periods. Values above 1 require super-Eddington episodes under this model.</a:t>
+                  <a:rPr lang="en-CA" sz="3300" b="0" i="0" dirty="0">
+                    <a:latin typeface="Aptos"/>
+                  </a:rPr>
+                  <a:t>: required lifetime average, including inactive periods. Values above 1 require periods of super-Eddington growth under this model.</a:t>
                 </a:r>
               </a:p>
               <a:p>
@@ -5684,7 +5767,7 @@
                   <a:rPr lang="en-CA" sz="3300" b="0" dirty="0">
                     <a:latin typeface="Aptos"/>
                   </a:rPr>
-                  <a:t> ≤ 3,400 using radiation-inclusive ages. Assumed access to fuel.</a:t>
+                  <a:t> ≤ 3,400 using radiation-inclusive ages. Assumed gas remained available for accretion.</a:t>
                 </a:r>
               </a:p>
             </p:txBody>
@@ -5706,7 +5789,7 @@
             <p:spPr>
               <a:xfrm>
                 <a:off x="1371600" y="11567160"/>
-                <a:ext cx="12573000" cy="12300611"/>
+                <a:ext cx="12573000" cy="13888226"/>
               </a:xfrm>
               <a:prstGeom prst="rect">
                 <a:avLst/>
@@ -5814,16 +5897,16 @@
                   <a:buNone/>
                 </a:pPr>
                 <a:r>
-                  <a:rPr sz="3300" b="1" i="0" lang="en-CA">
+                  <a:rPr sz="3300" b="1" lang="en-CA">
                     <a:latin typeface="Aptos"/>
                   </a:rPr>
                   <a:t>Model tests: </a:t>
                 </a:r>
                 <a:r>
-                  <a:rPr sz="3300" b="0" i="0" lang="en-CA">
-                    <a:latin typeface="Aptos"/>
-                  </a:rPr>
-                  <a:t>Calculated the average Eddington ratio required to reach each observed mass. Ranked these requirements and compared them with each model’s allowed average.</a:t>
+                  <a:rPr sz="3300" b="0" lang="en-CA">
+                    <a:latin typeface="Aptos"/>
+                  </a:rPr>
+                  <a:t>Calculated and ranked the lifetime-average Eddington ratios needed to reach each observed mass. Compared them with assumed caps: 1 for the reference test and 0.3, 1, or 2 for earlier-onset tests.</a:t>
                 </a:r>
               </a:p>
               <a:p>
@@ -5916,47 +5999,58 @@
                   <a:buNone/>
                 </a:pPr>
                 <a:r>
-                  <a:rPr sz="3300" b="1" i="0" lang="en-CA">
+                  <a:rPr lang="en-CA" sz="3300" b="1" i="0" dirty="0">
                     <a:latin typeface="Aptos"/>
                   </a:rPr>
                   <a:t>Eddington ratio: </a:t>
                 </a:r>
                 <a:r>
-                  <a:rPr sz="3300" b="0" i="1" lang="en-CA">
+                  <a:rPr lang="en-CA" sz="3300" b="0" i="1" dirty="0" err="1">
                     <a:latin typeface="Aptos"/>
                   </a:rPr>
                   <a:t>f</a:t>
                 </a:r>
                 <a:r>
-                  <a:rPr sz="2200" b="0" i="0" lang="en-CA" baseline="-25000">
+                  <a:rPr lang="en-CA" sz="2200" b="0" i="0" baseline="-25000" dirty="0" err="1">
                     <a:latin typeface="Aptos"/>
                   </a:rPr>
                   <a:t>Edd</a:t>
                 </a:r>
                 <a:r>
-                  <a:rPr sz="3300" b="0" i="0" lang="en-CA">
-                    <a:latin typeface="Aptos"/>
-                  </a:rPr>
-                  <a:t>: luminosity/Eddington limit.</a:t>
-                </a:r>
-                <a:br/>
-                <a:r>
-                  <a:rPr sz="3300" b="0" i="1" lang="en-CA">
+                  <a:rPr lang="en-CA" sz="3300" b="0" i="0" dirty="0">
+                    <a:latin typeface="Aptos"/>
+                  </a:rPr>
+                  <a:t> </a:t>
+                </a:r>
+                <a:r>
+                  <a:rPr lang="en-CA" sz="3300" b="1" i="0" dirty="0">
+                    <a:latin typeface="Aptos"/>
+                  </a:rPr>
+                  <a:t>: </a:t>
+                </a:r>
+                <a:r>
+                  <a:rPr lang="en-CA" sz="3300" b="0" i="0" dirty="0">
+                    <a:latin typeface="Aptos"/>
+                  </a:rPr>
+                  <a:t>luminosity/Eddington limit;  </a:t>
+                </a:r>
+                <a:r>
+                  <a:rPr lang="en-CA" sz="3300" b="0" i="1" dirty="0" err="1">
                     <a:latin typeface="Aptos"/>
                   </a:rPr>
                   <a:t>f̄</a:t>
                 </a:r>
                 <a:r>
-                  <a:rPr sz="2200" b="0" i="0" lang="en-CA" baseline="-25000">
+                  <a:rPr lang="en-CA" sz="2200" b="0" i="0" baseline="-25000" dirty="0" err="1">
                     <a:latin typeface="Aptos"/>
                   </a:rPr>
                   <a:t>Edd,req</a:t>
                 </a:r>
                 <a:r>
-                  <a:rPr sz="3300" b="0" i="0" lang="en-CA">
-                    <a:latin typeface="Aptos"/>
-                  </a:rPr>
-                  <a:t>: required lifetime average, including inactive periods. Values above 1 require super-Eddington episodes under this model.</a:t>
+                  <a:rPr lang="en-CA" sz="3300" b="0" i="0" dirty="0">
+                    <a:latin typeface="Aptos"/>
+                  </a:rPr>
+                  <a:t>: required lifetime average, including inactive periods. Values above 1 require periods of super-Eddington growth under this model.</a:t>
                 </a:r>
               </a:p>
               <a:p>
@@ -6034,7 +6128,7 @@
                   <a:rPr lang="en-CA" sz="3300" b="0" dirty="0">
                     <a:latin typeface="Aptos"/>
                   </a:rPr>
-                  <a:t> ≤ 3,400 using radiation-inclusive ages. Assumed access to fuel.</a:t>
+                  <a:t> ≤ 3,400 using radiation-inclusive ages. Assumed gas remained available for accretion.</a:t>
                 </a:r>
               </a:p>
             </p:txBody>
@@ -6191,91 +6285,76 @@
               <a:buChar char="•"/>
             </a:pPr>
             <a:r>
-              <a:rPr lang="en-CA" sz="3300" b="1" dirty="0">
+              <a:rPr sz="3300" b="1" lang="en-CA">
                 <a:latin typeface="Aptos"/>
               </a:rPr>
-              <a:t>Efficiency drives the tension: </a:t>
-            </a:r>
-            <a:r>
-              <a:rPr lang="en-CA" sz="3300" b="0" dirty="0">
+              <a:t>Radiative efficiency: </a:t>
+            </a:r>
+            <a:r>
+              <a:rPr sz="3300" b="0" lang="en-CA">
                 <a:latin typeface="Aptos"/>
               </a:rPr>
-              <a:t>Some objects challenge the reference model. At </a:t>
-            </a:r>
-            <a:r>
-              <a:rPr lang="en-CA" sz="3300" b="0" dirty="0" err="1">
+              <a:t>With 100 M⊙ seeds at z = 30, 8 primary objects require average ratios above 1 at ε = 0.1. At ε = 0.05719 (non-spinning thin disc), all 234 central masses require ratios below 1.</a:t>
+            </a:r>
+          </a:p>
+          <a:p>
+            <a:pPr marL="285750" indent="-228600">
+              <a:spcAft>
+                <a:spcPts val="800"/>
+              </a:spcAft>
+              <a:buChar char="•"/>
+            </a:pPr>
+            <a:r>
+              <a:rPr sz="3300" b="1" lang="en-CA">
                 <a:latin typeface="Aptos"/>
               </a:rPr>
-              <a:t>ε</a:t>
-            </a:r>
-            <a:r>
-              <a:rPr lang="en-CA" sz="3300" b="0" dirty="0">
+              <a:t>Mass measurements: </a:t>
+            </a:r>
+            <a:r>
+              <a:rPr sz="3300" b="0" lang="en-CA">
                 <a:latin typeface="Aptos"/>
               </a:rPr>
-              <a:t> = 0.05719, the ideal thin-disc efficiency for a non-spinning black hole, 100 M⊙ seeds at z = 30 reach all 234 central masses with an average ratio below 1.</a:t>
+              <a:t>Independent masses, improved lens models, and tests of scattering in broad emission lines could change which objects exceed the reference limit.</a:t>
             </a:r>
           </a:p>
           <a:p>
             <a:pPr marL="285750" indent="-228600">
+              <a:spcAft>
+                <a:spcPts val="800"/>
+              </a:spcAft>
               <a:buChar char="•"/>
             </a:pPr>
             <a:r>
-              <a:rPr lang="en-CA" sz="3300" b="1" dirty="0">
+              <a:rPr sz="3300" b="1" lang="en-CA">
                 <a:latin typeface="Aptos"/>
               </a:rPr>
-              <a:t>Independent mass estimates: </a:t>
-            </a:r>
-            <a:r>
-              <a:rPr lang="en-CA" sz="3300" b="0" dirty="0">
+              <a:t>Catalogue: </a:t>
+            </a:r>
+            <a:r>
+              <a:rPr sz="3300" b="0" lang="en-CA">
                 <a:latin typeface="Aptos"/>
               </a:rPr>
-              <a:t>Tests of calibration, lensing, and scattering are essential to establish which objects are most challenging.</a:t>
+              <a:t>The catalogue retains alternative measurements for comparison. Its counts combine different surveys and cannot show how common these black holes are.</a:t>
             </a:r>
           </a:p>
           <a:p>
             <a:pPr marL="285750" indent="-228600">
+              <a:spcAft>
+                <a:spcPts val="800"/>
+              </a:spcAft>
               <a:buChar char="•"/>
             </a:pPr>
             <a:r>
-              <a:rPr lang="en-CA" sz="3300" b="1" dirty="0">
+              <a:rPr sz="3300" b="1" lang="en-CA">
                 <a:latin typeface="Aptos"/>
               </a:rPr>
-              <a:t>Catalogue contribution: </a:t>
-            </a:r>
-            <a:r>
-              <a:rPr lang="en-CA" sz="3300" b="0" dirty="0">
+              <a:t>Earlier growth: </a:t>
+            </a:r>
+            <a:r>
+              <a:rPr sz="3300" b="0" lang="en-CA">
                 <a:latin typeface="Aptos"/>
               </a:rPr>
-              <a:t>Documented measurement choices and retained alternatives support consistent comparisons and follow-up. Sample counts describe the literature sample, not population fractions.</a:t>
-            </a:r>
-          </a:p>
-          <a:p>
-            <a:pPr marL="285750" indent="-228600">
-              <a:buChar char="•"/>
-            </a:pPr>
-            <a:r>
-              <a:rPr lang="en-CA" sz="3300" b="1" dirty="0">
-                <a:latin typeface="Aptos"/>
-              </a:rPr>
-              <a:t>Earlier onset offers limited relief: </a:t>
-            </a:r>
-            <a:r>
-              <a:rPr lang="en-CA" sz="3300" b="0" dirty="0">
-                <a:latin typeface="Aptos"/>
-              </a:rPr>
-              <a:t>Earlier onset alone cannot rescue 100 M⊙ seeds for the 4 targets at </a:t>
-            </a:r>
-            <a:r>
-              <a:rPr lang="en-CA" sz="3300" b="0" dirty="0" err="1">
-                <a:latin typeface="Aptos"/>
-              </a:rPr>
-              <a:t>ε</a:t>
-            </a:r>
-            <a:r>
-              <a:rPr lang="en-CA" sz="3300" b="0" dirty="0">
-                <a:latin typeface="Aptos"/>
-              </a:rPr>
-              <a:t> = 0.1, average ratio ≤ 1, and no mergers. Gains diminish at earlier onset. Growth compatibility does not establish primordial black hole (PBH) formation or abundance viability.</a:t>
+              <a:t>Starting at z = 3,400, the 4 targets still need 270–1,200 M⊙ seeds (ε = 0.1, average ratio ≤ 1, no mergers). Larger seeds or super-Eddington accretion remain possible explanations.</a:t>
             </a:r>
           </a:p>
         </p:txBody>
@@ -6973,7 +7052,7 @@
         <p:spPr>
           <a:xfrm>
             <a:off x="14950440" y="5120640"/>
-            <a:ext cx="28026360" cy="15727680"/>
+            <a:ext cx="28026360" cy="15956280"/>
           </a:xfrm>
           <a:prstGeom prst="rect">
             <a:avLst/>
@@ -7113,7 +7192,7 @@
               <a:rPr lang="en-CA" sz="2400" b="0" dirty="0">
                 <a:latin typeface="Aptos"/>
               </a:rPr>
-              <a:t>Earlier starts reduce required seeds, with diminishing gains.</a:t>
+              <a:t>Earlier starts lower the required seed mass, but the decrease becomes smaller.</a:t>
             </a:r>
           </a:p>
         </p:txBody>
@@ -7133,7 +7212,7 @@
         <p:spPr>
           <a:xfrm>
             <a:off x="29718000" y="18836640"/>
-            <a:ext cx="12801600" cy="1107996"/>
+            <a:ext cx="12801600" cy="2057400"/>
           </a:xfrm>
           <a:prstGeom prst="rect">
             <a:avLst/>
@@ -7154,18 +7233,41 @@
               <a:buChar char="•"/>
             </a:pPr>
             <a:r>
-              <a:rPr lang="en-CA" sz="3300" b="1" dirty="0">
+              <a:rPr sz="3300" b="1" lang="en-CA">
                 <a:latin typeface="Aptos"/>
               </a:rPr>
               <a:t>Independent mass check: </a:t>
             </a:r>
             <a:r>
-              <a:rPr lang="en-CA" sz="3300" b="0" dirty="0">
+              <a:rPr sz="3300" b="0" lang="en-CA">
                 <a:latin typeface="Aptos"/>
               </a:rPr>
-              <a:t>A2744-QSO1’s dynamical mass raises the ratio from 0.929 to ≈ 1; uncertainty spans 1 [5].</a:t>
-            </a:r>
-            <a:endParaRPr lang="en-CA" sz="3300" dirty="0"/>
+              <a:t>For A2744-QSO1, the broad-line mass (2.0 × 10</a:t>
+            </a:r>
+            <a:r>
+              <a:rPr sz="2200" b="0" lang="en-CA" baseline="30000">
+                <a:latin typeface="Aptos"/>
+              </a:rPr>
+              <a:t>7</a:t>
+            </a:r>
+            <a:r>
+              <a:rPr sz="3300" b="0" lang="en-CA">
+                <a:latin typeface="Aptos"/>
+              </a:rPr>
+              <a:t> M⊙) requires an average ratio of 0.929. The dynamical mass (5.0 × 10</a:t>
+            </a:r>
+            <a:r>
+              <a:rPr sz="2200" b="0" lang="en-CA" baseline="30000">
+                <a:latin typeface="Aptos"/>
+              </a:rPr>
+              <a:t>7</a:t>
+            </a:r>
+            <a:r>
+              <a:rPr sz="3300" b="0" lang="en-CA">
+                <a:latin typeface="Aptos"/>
+              </a:rPr>
+              <a:t> M⊙) requires 0.9996 (16th–84th percentiles: 0.947–1.052) [5].</a:t>
+            </a:r>
           </a:p>
         </p:txBody>
       </p:sp>
@@ -7219,15 +7321,13 @@
               </a:defRPr>
             </a:pPr>
             <a:r>
-              <a:rPr sz="3600" b="1">
+              <a:rPr sz="3600" b="1" lang="en-CA">
                 <a:solidFill>
                   <a:srgbClr val="002A5C"/>
                 </a:solidFill>
                 <a:latin typeface="Aptos"/>
-                <a:ea typeface="Aptos"/>
-                <a:cs typeface="Aptos"/>
               </a:rPr>
-              <a:t>Growth tension depends on efficiency</a:t>
+              <a:t>Growth at two radiative efficiencies</a:t>
             </a:r>
           </a:p>
         </p:txBody>

</xml_diff>